<commit_message>
auto: atualizacao do projeto 2026-04-28_2210
</commit_message>
<xml_diff>
--- a/operacoes/apresentacoes/monica/Pitch-Monica.pptx
+++ b/operacoes/apresentacoes/monica/Pitch-Monica.pptx
@@ -3632,7 +3632,7 @@
         </p:nvSpPr>
         <p:spPr>
           <a:xfrm>
-            <a:off x="1371600" y="2880360"/>
+            <a:off x="1371600" y="2788920"/>
             <a:ext cx="2194560" cy="411480"/>
           </a:xfrm>
           <a:prstGeom prst="rect">
@@ -3671,7 +3671,7 @@
         </p:nvSpPr>
         <p:spPr>
           <a:xfrm>
-            <a:off x="3840480" y="2880360"/>
+            <a:off x="3840480" y="2788920"/>
             <a:ext cx="2286000" cy="411480"/>
           </a:xfrm>
           <a:prstGeom prst="rect">
@@ -3710,7 +3710,7 @@
         </p:nvSpPr>
         <p:spPr>
           <a:xfrm>
-            <a:off x="6400800" y="2880360"/>
+            <a:off x="6400800" y="2788920"/>
             <a:ext cx="2468880" cy="411480"/>
           </a:xfrm>
           <a:prstGeom prst="rect">
@@ -3749,7 +3749,7 @@
         </p:nvSpPr>
         <p:spPr>
           <a:xfrm>
-            <a:off x="9144000" y="2880360"/>
+            <a:off x="9144000" y="2788920"/>
             <a:ext cx="2560320" cy="411480"/>
           </a:xfrm>
           <a:prstGeom prst="rect">
@@ -3788,7 +3788,7 @@
         </p:nvSpPr>
         <p:spPr>
           <a:xfrm>
-            <a:off x="1188720" y="3474720"/>
+            <a:off x="1188720" y="3291840"/>
             <a:ext cx="10241280" cy="594360"/>
           </a:xfrm>
           <a:prstGeom prst="rect">
@@ -3815,7 +3815,7 @@
         </p:nvSpPr>
         <p:spPr>
           <a:xfrm>
-            <a:off x="1371600" y="3566160"/>
+            <a:off x="1371600" y="3383280"/>
             <a:ext cx="2194560" cy="411480"/>
           </a:xfrm>
           <a:prstGeom prst="rect">
@@ -3854,7 +3854,7 @@
         </p:nvSpPr>
         <p:spPr>
           <a:xfrm>
-            <a:off x="3840480" y="3566160"/>
+            <a:off x="3840480" y="3383280"/>
             <a:ext cx="2286000" cy="411480"/>
           </a:xfrm>
           <a:prstGeom prst="rect">
@@ -3893,7 +3893,7 @@
         </p:nvSpPr>
         <p:spPr>
           <a:xfrm>
-            <a:off x="6400800" y="3566160"/>
+            <a:off x="6400800" y="3383280"/>
             <a:ext cx="2468880" cy="411480"/>
           </a:xfrm>
           <a:prstGeom prst="rect">
@@ -3932,7 +3932,7 @@
         </p:nvSpPr>
         <p:spPr>
           <a:xfrm>
-            <a:off x="9144000" y="3566160"/>
+            <a:off x="9144000" y="3383280"/>
             <a:ext cx="2560320" cy="411480"/>
           </a:xfrm>
           <a:prstGeom prst="rect">
@@ -3971,7 +3971,7 @@
         </p:nvSpPr>
         <p:spPr>
           <a:xfrm>
-            <a:off x="914400" y="3794760"/>
+            <a:off x="914400" y="4114800"/>
             <a:ext cx="5180076" cy="1005840"/>
           </a:xfrm>
           <a:prstGeom prst="rect">
@@ -4010,7 +4010,7 @@
         </p:nvSpPr>
         <p:spPr>
           <a:xfrm>
-            <a:off x="914400" y="4800600"/>
+            <a:off x="914400" y="5120640"/>
             <a:ext cx="5180076" cy="502920"/>
           </a:xfrm>
           <a:prstGeom prst="rect">
@@ -4072,7 +4072,7 @@
         </p:nvSpPr>
         <p:spPr>
           <a:xfrm>
-            <a:off x="6076188" y="3749040"/>
+            <a:off x="6076188" y="4069080"/>
             <a:ext cx="36576" cy="1645920"/>
           </a:xfrm>
           <a:prstGeom prst="rect">
@@ -4097,7 +4097,7 @@
         </p:nvSpPr>
         <p:spPr>
           <a:xfrm>
-            <a:off x="6551676" y="3794760"/>
+            <a:off x="6551676" y="4114800"/>
             <a:ext cx="4997196" cy="1005840"/>
           </a:xfrm>
           <a:prstGeom prst="rect">
@@ -4136,7 +4136,7 @@
         </p:nvSpPr>
         <p:spPr>
           <a:xfrm>
-            <a:off x="6551676" y="4800600"/>
+            <a:off x="6551676" y="5120640"/>
             <a:ext cx="4997196" cy="502920"/>
           </a:xfrm>
           <a:prstGeom prst="rect">
@@ -4198,7 +4198,7 @@
         </p:nvSpPr>
         <p:spPr>
           <a:xfrm>
-            <a:off x="1371600" y="5532120"/>
+            <a:off x="1371600" y="5806440"/>
             <a:ext cx="9445752" cy="320040"/>
           </a:xfrm>
           <a:prstGeom prst="rect">
@@ -4237,7 +4237,7 @@
         </p:nvSpPr>
         <p:spPr>
           <a:xfrm>
-            <a:off x="1371600" y="5897880"/>
+            <a:off x="1371600" y="6217920"/>
             <a:ext cx="9445752" cy="320040"/>
           </a:xfrm>
           <a:prstGeom prst="rect">
@@ -4512,8 +4512,8 @@
         </p:nvSpPr>
         <p:spPr>
           <a:xfrm>
-            <a:off x="1371600" y="3429000"/>
-            <a:ext cx="365760" cy="502920"/>
+            <a:off x="1371600" y="3383280"/>
+            <a:ext cx="365760" cy="640080"/>
           </a:xfrm>
           <a:prstGeom prst="rect">
             <a:avLst/>
@@ -4551,8 +4551,8 @@
         </p:nvSpPr>
         <p:spPr>
           <a:xfrm>
-            <a:off x="1874520" y="3429000"/>
-            <a:ext cx="8897112" cy="502920"/>
+            <a:off x="1874520" y="3383280"/>
+            <a:ext cx="8897112" cy="640080"/>
           </a:xfrm>
           <a:prstGeom prst="rect">
             <a:avLst/>
@@ -4571,7 +4571,7 @@
               <a:buNone/>
             </a:pPr>
             <a:r>
-              <a:rPr lang="en-US" sz="1500" b="1" dirty="0">
+              <a:rPr lang="en-US" sz="1400" b="1" dirty="0">
                 <a:solidFill>
                   <a:srgbClr val="FFFFFF"/>
                 </a:solidFill>
@@ -4588,7 +4588,7 @@
               <a:buNone/>
             </a:pPr>
             <a:r>
-              <a:rPr lang="en-US" sz="1500" dirty="0">
+              <a:rPr lang="en-US" sz="1400" dirty="0">
                 <a:solidFill>
                   <a:srgbClr val="9CA3AF"/>
                 </a:solidFill>
@@ -4598,7 +4598,7 @@
               </a:rPr>
               <a:t> — você acompanha em tempo real.</a:t>
             </a:r>
-            <a:endParaRPr lang="en-US" sz="1500" dirty="0"/>
+            <a:endParaRPr lang="en-US" sz="1400" dirty="0"/>
           </a:p>
         </p:txBody>
       </p:sp>
@@ -4610,8 +4610,8 @@
         </p:nvSpPr>
         <p:spPr>
           <a:xfrm>
-            <a:off x="1371600" y="4087368"/>
-            <a:ext cx="365760" cy="502920"/>
+            <a:off x="1371600" y="4133088"/>
+            <a:ext cx="365760" cy="640080"/>
           </a:xfrm>
           <a:prstGeom prst="rect">
             <a:avLst/>
@@ -4649,8 +4649,8 @@
         </p:nvSpPr>
         <p:spPr>
           <a:xfrm>
-            <a:off x="1874520" y="4087368"/>
-            <a:ext cx="8897112" cy="502920"/>
+            <a:off x="1874520" y="4133088"/>
+            <a:ext cx="8897112" cy="640080"/>
           </a:xfrm>
           <a:prstGeom prst="rect">
             <a:avLst/>
@@ -4669,7 +4669,7 @@
               <a:buNone/>
             </a:pPr>
             <a:r>
-              <a:rPr lang="en-US" sz="1500" b="1" dirty="0">
+              <a:rPr lang="en-US" sz="1400" b="1" dirty="0">
                 <a:solidFill>
                   <a:srgbClr val="FFFFFF"/>
                 </a:solidFill>
@@ -4686,7 +4686,7 @@
               <a:buNone/>
             </a:pPr>
             <a:r>
-              <a:rPr lang="en-US" sz="1500" dirty="0">
+              <a:rPr lang="en-US" sz="1400" dirty="0">
                 <a:solidFill>
                   <a:srgbClr val="9CA3AF"/>
                 </a:solidFill>
@@ -4696,7 +4696,7 @@
               </a:rPr>
               <a:t> — nada é usado fora desta parceria sem sua autorização.</a:t>
             </a:r>
-            <a:endParaRPr lang="en-US" sz="1500" dirty="0"/>
+            <a:endParaRPr lang="en-US" sz="1400" dirty="0"/>
           </a:p>
         </p:txBody>
       </p:sp>
@@ -4708,8 +4708,8 @@
         </p:nvSpPr>
         <p:spPr>
           <a:xfrm>
-            <a:off x="1371600" y="4745736"/>
-            <a:ext cx="365760" cy="502920"/>
+            <a:off x="1371600" y="4882896"/>
+            <a:ext cx="365760" cy="640080"/>
           </a:xfrm>
           <a:prstGeom prst="rect">
             <a:avLst/>
@@ -4747,8 +4747,8 @@
         </p:nvSpPr>
         <p:spPr>
           <a:xfrm>
-            <a:off x="1874520" y="4745736"/>
-            <a:ext cx="8897112" cy="502920"/>
+            <a:off x="1874520" y="4882896"/>
+            <a:ext cx="8897112" cy="640080"/>
           </a:xfrm>
           <a:prstGeom prst="rect">
             <a:avLst/>
@@ -4767,7 +4767,7 @@
               <a:buNone/>
             </a:pPr>
             <a:r>
-              <a:rPr lang="en-US" sz="1500" b="1" dirty="0">
+              <a:rPr lang="en-US" sz="1400" b="1" dirty="0">
                 <a:solidFill>
                   <a:srgbClr val="FFFFFF"/>
                 </a:solidFill>
@@ -4784,7 +4784,7 @@
               <a:buNone/>
             </a:pPr>
             <a:r>
-              <a:rPr lang="en-US" sz="1500" dirty="0">
+              <a:rPr lang="en-US" sz="1400" dirty="0">
                 <a:solidFill>
                   <a:srgbClr val="9CA3AF"/>
                 </a:solidFill>
@@ -4794,7 +4794,7 @@
               </a:rPr>
               <a:t> — você mantém todos os seus projetos e atendimentos.</a:t>
             </a:r>
-            <a:endParaRPr lang="en-US" sz="1500" dirty="0"/>
+            <a:endParaRPr lang="en-US" sz="1400" dirty="0"/>
           </a:p>
         </p:txBody>
       </p:sp>
@@ -4806,8 +4806,8 @@
         </p:nvSpPr>
         <p:spPr>
           <a:xfrm>
-            <a:off x="1371600" y="5404104"/>
-            <a:ext cx="365760" cy="502920"/>
+            <a:off x="1371600" y="5632704"/>
+            <a:ext cx="365760" cy="640080"/>
           </a:xfrm>
           <a:prstGeom prst="rect">
             <a:avLst/>
@@ -4845,8 +4845,8 @@
         </p:nvSpPr>
         <p:spPr>
           <a:xfrm>
-            <a:off x="1874520" y="5404104"/>
-            <a:ext cx="8897112" cy="502920"/>
+            <a:off x="1874520" y="5632704"/>
+            <a:ext cx="8897112" cy="640080"/>
           </a:xfrm>
           <a:prstGeom prst="rect">
             <a:avLst/>
@@ -4865,7 +4865,7 @@
               <a:buNone/>
             </a:pPr>
             <a:r>
-              <a:rPr lang="en-US" sz="1500" b="1" dirty="0">
+              <a:rPr lang="en-US" sz="1400" b="1" dirty="0">
                 <a:solidFill>
                   <a:srgbClr val="FFFFFF"/>
                 </a:solidFill>
@@ -4882,7 +4882,7 @@
               <a:buNone/>
             </a:pPr>
             <a:r>
-              <a:rPr lang="en-US" sz="1500" dirty="0">
+              <a:rPr lang="en-US" sz="1400" dirty="0">
                 <a:solidFill>
                   <a:srgbClr val="9CA3AF"/>
                 </a:solidFill>
@@ -4892,7 +4892,7 @@
               </a:rPr>
               <a:t> — se quiser sair, a operação tem transição estruturada.</a:t>
             </a:r>
-            <a:endParaRPr lang="en-US" sz="1500" dirty="0"/>
+            <a:endParaRPr lang="en-US" sz="1400" dirty="0"/>
           </a:p>
         </p:txBody>
       </p:sp>
@@ -4904,7 +4904,7 @@
         </p:nvSpPr>
         <p:spPr>
           <a:xfrm>
-            <a:off x="1371600" y="6080760"/>
+            <a:off x="1371600" y="6400800"/>
             <a:ext cx="9445752" cy="594360"/>
           </a:xfrm>
           <a:prstGeom prst="rect">
@@ -12193,39 +12193,16 @@
           </a:ln>
         </p:spPr>
       </p:sp>
-      <p:pic>
-        <p:nvPicPr>
-          <p:cNvPr id="5" name="Image 0" descr="c:/Users/Desktop/Downloads/grupoaura/operacoes/apresentacoes/monica/foto-prisciane.jpg">    </p:cNvPr>
-          <p:cNvPicPr>
-            <a:picLocks noChangeAspect="1"/>
-          </p:cNvPicPr>
-          <p:nvPr/>
-        </p:nvPicPr>
-        <p:blipFill>
-          <a:blip r:embed="rId1"/>
-          <a:srcRect l="0" r="0" t="0" b="0"/>
-          <a:stretch/>
-        </p:blipFill>
-        <p:spPr>
-          <a:xfrm>
-            <a:off x="914400" y="1143000"/>
-            <a:ext cx="594360" cy="594360"/>
-          </a:xfrm>
-          <a:prstGeom prst="rect">
-            <a:avLst/>
-          </a:prstGeom>
-        </p:spPr>
-      </p:pic>
-      <p:sp>
-        <p:nvSpPr>
-          <p:cNvPr id="6" name="Text 3"/>
-          <p:cNvSpPr/>
-          <p:nvPr/>
-        </p:nvSpPr>
-        <p:spPr>
-          <a:xfrm>
-            <a:off x="1600200" y="1188720"/>
-            <a:ext cx="4114800" cy="274320"/>
+      <p:sp>
+        <p:nvSpPr>
+          <p:cNvPr id="5" name="Text 3"/>
+          <p:cNvSpPr/>
+          <p:nvPr/>
+        </p:nvSpPr>
+        <p:spPr>
+          <a:xfrm>
+            <a:off x="914400" y="1188720"/>
+            <a:ext cx="4754880" cy="274320"/>
           </a:xfrm>
           <a:prstGeom prst="rect">
             <a:avLst/>
@@ -12257,14 +12234,14 @@
       </p:sp>
       <p:sp>
         <p:nvSpPr>
-          <p:cNvPr id="7" name="Text 4"/>
-          <p:cNvSpPr/>
-          <p:nvPr/>
-        </p:nvSpPr>
-        <p:spPr>
-          <a:xfrm>
-            <a:off x="1600200" y="1481328"/>
-            <a:ext cx="4114800" cy="347472"/>
+          <p:cNvPr id="6" name="Text 4"/>
+          <p:cNvSpPr/>
+          <p:nvPr/>
+        </p:nvSpPr>
+        <p:spPr>
+          <a:xfrm>
+            <a:off x="914400" y="1481328"/>
+            <a:ext cx="4754880" cy="347472"/>
           </a:xfrm>
           <a:prstGeom prst="rect">
             <a:avLst/>
@@ -12296,7 +12273,7 @@
       </p:sp>
       <p:sp>
         <p:nvSpPr>
-          <p:cNvPr id="8" name="Text 5"/>
+          <p:cNvPr id="7" name="Text 5"/>
           <p:cNvSpPr/>
           <p:nvPr/>
         </p:nvSpPr>
@@ -12335,7 +12312,7 @@
       </p:sp>
       <p:sp>
         <p:nvSpPr>
-          <p:cNvPr id="9" name="Text 6"/>
+          <p:cNvPr id="8" name="Text 6"/>
           <p:cNvSpPr/>
           <p:nvPr/>
         </p:nvSpPr>
@@ -12374,7 +12351,7 @@
       </p:sp>
       <p:sp>
         <p:nvSpPr>
-          <p:cNvPr id="10" name="Shape 7"/>
+          <p:cNvPr id="9" name="Shape 7"/>
           <p:cNvSpPr/>
           <p:nvPr/>
         </p:nvSpPr>
@@ -12399,7 +12376,7 @@
       </p:sp>
       <p:sp>
         <p:nvSpPr>
-          <p:cNvPr id="11" name="Text 8"/>
+          <p:cNvPr id="10" name="Text 8"/>
           <p:cNvSpPr/>
           <p:nvPr/>
         </p:nvSpPr>
@@ -12501,7 +12478,7 @@
       </p:sp>
       <p:sp>
         <p:nvSpPr>
-          <p:cNvPr id="12" name="Text 9"/>
+          <p:cNvPr id="11" name="Text 9"/>
           <p:cNvSpPr/>
           <p:nvPr/>
         </p:nvSpPr>
@@ -12540,7 +12517,7 @@
       </p:sp>
       <p:sp>
         <p:nvSpPr>
-          <p:cNvPr id="13" name="Shape 10"/>
+          <p:cNvPr id="12" name="Shape 10"/>
           <p:cNvSpPr/>
           <p:nvPr/>
         </p:nvSpPr>
@@ -12567,14 +12544,14 @@
       </p:sp>
       <p:pic>
         <p:nvPicPr>
-          <p:cNvPr id="14" name="Image 1" descr="c:/Users/Desktop/Downloads/grupoaura/operacoes/apresentacoes/monica/foto-fealves.jpg">    </p:cNvPr>
+          <p:cNvPr id="13" name="Image 0" descr="c:/Users/Desktop/Downloads/grupoaura/operacoes/apresentacoes/monica/foto-fealves.jpg">    </p:cNvPr>
           <p:cNvPicPr>
             <a:picLocks noChangeAspect="1"/>
           </p:cNvPicPr>
           <p:nvPr/>
         </p:nvPicPr>
         <p:blipFill>
-          <a:blip r:embed="rId2"/>
+          <a:blip r:embed="rId1"/>
           <a:srcRect l="0" r="0" t="0" b="0"/>
           <a:stretch/>
         </p:blipFill>
@@ -12590,7 +12567,7 @@
       </p:pic>
       <p:sp>
         <p:nvSpPr>
-          <p:cNvPr id="15" name="Text 11"/>
+          <p:cNvPr id="14" name="Text 11"/>
           <p:cNvSpPr/>
           <p:nvPr/>
         </p:nvSpPr>
@@ -12629,7 +12606,7 @@
       </p:sp>
       <p:sp>
         <p:nvSpPr>
-          <p:cNvPr id="16" name="Text 12"/>
+          <p:cNvPr id="15" name="Text 12"/>
           <p:cNvSpPr/>
           <p:nvPr/>
         </p:nvSpPr>
@@ -12668,7 +12645,7 @@
       </p:sp>
       <p:sp>
         <p:nvSpPr>
-          <p:cNvPr id="17" name="Text 13"/>
+          <p:cNvPr id="16" name="Text 13"/>
           <p:cNvSpPr/>
           <p:nvPr/>
         </p:nvSpPr>
@@ -12707,7 +12684,7 @@
       </p:sp>
       <p:sp>
         <p:nvSpPr>
-          <p:cNvPr id="18" name="Text 14"/>
+          <p:cNvPr id="17" name="Text 14"/>
           <p:cNvSpPr/>
           <p:nvPr/>
         </p:nvSpPr>
@@ -12746,7 +12723,7 @@
       </p:sp>
       <p:sp>
         <p:nvSpPr>
-          <p:cNvPr id="19" name="Shape 15"/>
+          <p:cNvPr id="18" name="Shape 15"/>
           <p:cNvSpPr/>
           <p:nvPr/>
         </p:nvSpPr>
@@ -12771,7 +12748,7 @@
       </p:sp>
       <p:sp>
         <p:nvSpPr>
-          <p:cNvPr id="20" name="Text 16"/>
+          <p:cNvPr id="19" name="Text 16"/>
           <p:cNvSpPr/>
           <p:nvPr/>
         </p:nvSpPr>
@@ -12873,7 +12850,7 @@
       </p:sp>
       <p:sp>
         <p:nvSpPr>
-          <p:cNvPr id="21" name="Text 17"/>
+          <p:cNvPr id="20" name="Text 17"/>
           <p:cNvSpPr/>
           <p:nvPr/>
         </p:nvSpPr>
@@ -12912,7 +12889,7 @@
       </p:sp>
       <p:sp>
         <p:nvSpPr>
-          <p:cNvPr id="22" name="Text 18"/>
+          <p:cNvPr id="21" name="Text 18"/>
           <p:cNvSpPr/>
           <p:nvPr/>
         </p:nvSpPr>

</xml_diff>

<commit_message>
auto: atualizacao do projeto 2026-04-28_2214
</commit_message>
<xml_diff>
--- a/operacoes/apresentacoes/monica/Pitch-Monica.pptx
+++ b/operacoes/apresentacoes/monica/Pitch-Monica.pptx
@@ -12193,16 +12193,39 @@
           </a:ln>
         </p:spPr>
       </p:sp>
-      <p:sp>
-        <p:nvSpPr>
-          <p:cNvPr id="5" name="Text 3"/>
-          <p:cNvSpPr/>
-          <p:nvPr/>
-        </p:nvSpPr>
-        <p:spPr>
-          <a:xfrm>
-            <a:off x="914400" y="1188720"/>
-            <a:ext cx="4754880" cy="274320"/>
+      <p:pic>
+        <p:nvPicPr>
+          <p:cNvPr id="5" name="Image 0" descr="c:/Users/Desktop/Downloads/grupoaura/operacoes/apresentacoes/monica/foto-prisciane.jpg">    </p:cNvPr>
+          <p:cNvPicPr>
+            <a:picLocks noChangeAspect="1"/>
+          </p:cNvPicPr>
+          <p:nvPr/>
+        </p:nvPicPr>
+        <p:blipFill>
+          <a:blip r:embed="rId1"/>
+          <a:srcRect l="0" r="0" t="0" b="0"/>
+          <a:stretch/>
+        </p:blipFill>
+        <p:spPr>
+          <a:xfrm>
+            <a:off x="914400" y="1143000"/>
+            <a:ext cx="594360" cy="594360"/>
+          </a:xfrm>
+          <a:prstGeom prst="rect">
+            <a:avLst/>
+          </a:prstGeom>
+        </p:spPr>
+      </p:pic>
+      <p:sp>
+        <p:nvSpPr>
+          <p:cNvPr id="6" name="Text 3"/>
+          <p:cNvSpPr/>
+          <p:nvPr/>
+        </p:nvSpPr>
+        <p:spPr>
+          <a:xfrm>
+            <a:off x="1600200" y="1188720"/>
+            <a:ext cx="4114800" cy="274320"/>
           </a:xfrm>
           <a:prstGeom prst="rect">
             <a:avLst/>
@@ -12234,14 +12257,14 @@
       </p:sp>
       <p:sp>
         <p:nvSpPr>
-          <p:cNvPr id="6" name="Text 4"/>
-          <p:cNvSpPr/>
-          <p:nvPr/>
-        </p:nvSpPr>
-        <p:spPr>
-          <a:xfrm>
-            <a:off x="914400" y="1481328"/>
-            <a:ext cx="4754880" cy="347472"/>
+          <p:cNvPr id="7" name="Text 4"/>
+          <p:cNvSpPr/>
+          <p:nvPr/>
+        </p:nvSpPr>
+        <p:spPr>
+          <a:xfrm>
+            <a:off x="1600200" y="1481328"/>
+            <a:ext cx="4114800" cy="347472"/>
           </a:xfrm>
           <a:prstGeom prst="rect">
             <a:avLst/>
@@ -12273,7 +12296,7 @@
       </p:sp>
       <p:sp>
         <p:nvSpPr>
-          <p:cNvPr id="7" name="Text 5"/>
+          <p:cNvPr id="8" name="Text 5"/>
           <p:cNvSpPr/>
           <p:nvPr/>
         </p:nvSpPr>
@@ -12312,7 +12335,7 @@
       </p:sp>
       <p:sp>
         <p:nvSpPr>
-          <p:cNvPr id="8" name="Text 6"/>
+          <p:cNvPr id="9" name="Text 6"/>
           <p:cNvSpPr/>
           <p:nvPr/>
         </p:nvSpPr>
@@ -12351,7 +12374,7 @@
       </p:sp>
       <p:sp>
         <p:nvSpPr>
-          <p:cNvPr id="9" name="Shape 7"/>
+          <p:cNvPr id="10" name="Shape 7"/>
           <p:cNvSpPr/>
           <p:nvPr/>
         </p:nvSpPr>
@@ -12376,7 +12399,7 @@
       </p:sp>
       <p:sp>
         <p:nvSpPr>
-          <p:cNvPr id="10" name="Text 8"/>
+          <p:cNvPr id="11" name="Text 8"/>
           <p:cNvSpPr/>
           <p:nvPr/>
         </p:nvSpPr>
@@ -12478,7 +12501,7 @@
       </p:sp>
       <p:sp>
         <p:nvSpPr>
-          <p:cNvPr id="11" name="Text 9"/>
+          <p:cNvPr id="12" name="Text 9"/>
           <p:cNvSpPr/>
           <p:nvPr/>
         </p:nvSpPr>
@@ -12517,7 +12540,7 @@
       </p:sp>
       <p:sp>
         <p:nvSpPr>
-          <p:cNvPr id="12" name="Shape 10"/>
+          <p:cNvPr id="13" name="Shape 10"/>
           <p:cNvSpPr/>
           <p:nvPr/>
         </p:nvSpPr>
@@ -12544,14 +12567,14 @@
       </p:sp>
       <p:pic>
         <p:nvPicPr>
-          <p:cNvPr id="13" name="Image 0" descr="c:/Users/Desktop/Downloads/grupoaura/operacoes/apresentacoes/monica/foto-fealves.jpg">    </p:cNvPr>
+          <p:cNvPr id="14" name="Image 1" descr="c:/Users/Desktop/Downloads/grupoaura/operacoes/apresentacoes/monica/foto-fealves.jpg">    </p:cNvPr>
           <p:cNvPicPr>
             <a:picLocks noChangeAspect="1"/>
           </p:cNvPicPr>
           <p:nvPr/>
         </p:nvPicPr>
         <p:blipFill>
-          <a:blip r:embed="rId1"/>
+          <a:blip r:embed="rId2"/>
           <a:srcRect l="0" r="0" t="0" b="0"/>
           <a:stretch/>
         </p:blipFill>
@@ -12567,7 +12590,7 @@
       </p:pic>
       <p:sp>
         <p:nvSpPr>
-          <p:cNvPr id="14" name="Text 11"/>
+          <p:cNvPr id="15" name="Text 11"/>
           <p:cNvSpPr/>
           <p:nvPr/>
         </p:nvSpPr>
@@ -12606,7 +12629,7 @@
       </p:sp>
       <p:sp>
         <p:nvSpPr>
-          <p:cNvPr id="15" name="Text 12"/>
+          <p:cNvPr id="16" name="Text 12"/>
           <p:cNvSpPr/>
           <p:nvPr/>
         </p:nvSpPr>
@@ -12645,7 +12668,7 @@
       </p:sp>
       <p:sp>
         <p:nvSpPr>
-          <p:cNvPr id="16" name="Text 13"/>
+          <p:cNvPr id="17" name="Text 13"/>
           <p:cNvSpPr/>
           <p:nvPr/>
         </p:nvSpPr>
@@ -12684,7 +12707,7 @@
       </p:sp>
       <p:sp>
         <p:nvSpPr>
-          <p:cNvPr id="17" name="Text 14"/>
+          <p:cNvPr id="18" name="Text 14"/>
           <p:cNvSpPr/>
           <p:nvPr/>
         </p:nvSpPr>
@@ -12723,7 +12746,7 @@
       </p:sp>
       <p:sp>
         <p:nvSpPr>
-          <p:cNvPr id="18" name="Shape 15"/>
+          <p:cNvPr id="19" name="Shape 15"/>
           <p:cNvSpPr/>
           <p:nvPr/>
         </p:nvSpPr>
@@ -12748,7 +12771,7 @@
       </p:sp>
       <p:sp>
         <p:nvSpPr>
-          <p:cNvPr id="19" name="Text 16"/>
+          <p:cNvPr id="20" name="Text 16"/>
           <p:cNvSpPr/>
           <p:nvPr/>
         </p:nvSpPr>
@@ -12850,7 +12873,7 @@
       </p:sp>
       <p:sp>
         <p:nvSpPr>
-          <p:cNvPr id="20" name="Text 17"/>
+          <p:cNvPr id="21" name="Text 17"/>
           <p:cNvSpPr/>
           <p:nvPr/>
         </p:nvSpPr>
@@ -12889,7 +12912,7 @@
       </p:sp>
       <p:sp>
         <p:nvSpPr>
-          <p:cNvPr id="21" name="Text 18"/>
+          <p:cNvPr id="22" name="Text 18"/>
           <p:cNvSpPr/>
           <p:nvPr/>
         </p:nvSpPr>

</xml_diff>